<commit_message>
Split Session 2 framing slides into their own deck
Move the Session 2 lab-framing slides out of workshop-extras into
session2/01-session2-hands-on.pptx (built by build_session2.py from a
Marp markdown source), alongside the extracted memory-model and
k-induction companion decks. Shared python-pptx helpers move to
pptx_helpers.py; widescreen.py records the 4:3 to 16:9 conversion.
</commit_message>
<xml_diff>
--- a/slides/workshop-extras.pptx
+++ b/slides/workshop-extras.pptx
@@ -17,15 +17,6 @@
     <p:sldId id="265" r:id="rId16"/>
     <p:sldId id="266" r:id="rId17"/>
     <p:sldId id="267" r:id="rId18"/>
-    <p:sldId id="268" r:id="rId19"/>
-    <p:sldId id="269" r:id="rId20"/>
-    <p:sldId id="270" r:id="rId21"/>
-    <p:sldId id="271" r:id="rId22"/>
-    <p:sldId id="272" r:id="rId23"/>
-    <p:sldId id="273" r:id="rId24"/>
-    <p:sldId id="274" r:id="rId25"/>
-    <p:sldId id="275" r:id="rId26"/>
-    <p:sldId id="276" r:id="rId27"/>
   </p:sldIdLst>
   <p:sldSz cx="12191695" cy="6858000" type="screen4x3"/>
   <p:notesSz cx="6858000" cy="9144000"/>
@@ -3641,1496 +3632,6 @@
                 </a:solidFill>
               </a:rPr>
               <a:t>Can't make it work? Come at 17:45 — we'll fix it together.</a:t>
-            </a:r>
-          </a:p>
-        </p:txBody>
-      </p:sp>
-    </p:spTree>
-  </p:cSld>
-  <p:clrMapOvr>
-    <a:masterClrMapping/>
-  </p:clrMapOvr>
-</p:sld>
-</file>
-
-<file path=ppt/slides/slide13.xml><?xml version="1.0" encoding="utf-8"?>
-<p:sld xmlns:a="http://schemas.openxmlformats.org/drawingml/2006/main" xmlns:p="http://schemas.openxmlformats.org/presentationml/2006/main" xmlns:r="http://schemas.openxmlformats.org/officeDocument/2006/relationships">
-  <p:cSld>
-    <p:spTree>
-      <p:nvGrpSpPr>
-        <p:cNvPr id="1" name=""/>
-        <p:cNvGrpSpPr/>
-        <p:nvPr/>
-      </p:nvGrpSpPr>
-      <p:grpSpPr/>
-      <p:sp>
-        <p:nvSpPr>
-          <p:cNvPr id="2" name="TextBox 1"/>
-          <p:cNvSpPr txBox="1"/>
-          <p:nvPr/>
-        </p:nvSpPr>
-        <p:spPr>
-          <a:xfrm>
-            <a:off x="548640" y="2377440"/>
-            <a:ext cx="11064240" cy="1005840"/>
-          </a:xfrm>
-          <a:prstGeom prst="rect">
-            <a:avLst/>
-          </a:prstGeom>
-          <a:noFill/>
-        </p:spPr>
-        <p:txBody>
-          <a:bodyPr wrap="square">
-            <a:spAutoFit/>
-          </a:bodyPr>
-          <a:lstStyle/>
-          <a:p>
-            <a:r>
-              <a:rPr sz="4400" b="1">
-                <a:solidFill>
-                  <a:srgbClr val="5A0A7A"/>
-                </a:solidFill>
-              </a:rPr>
-              <a:t>Formal Verification Workshop</a:t>
-            </a:r>
-          </a:p>
-        </p:txBody>
-      </p:sp>
-      <p:sp>
-        <p:nvSpPr>
-          <p:cNvPr id="3" name="TextBox 2"/>
-          <p:cNvSpPr txBox="1"/>
-          <p:nvPr/>
-        </p:nvSpPr>
-        <p:spPr>
-          <a:xfrm>
-            <a:off x="731520" y="3566160"/>
-            <a:ext cx="10789920" cy="3017520"/>
-          </a:xfrm>
-          <a:prstGeom prst="rect">
-            <a:avLst/>
-          </a:prstGeom>
-          <a:noFill/>
-        </p:spPr>
-        <p:txBody>
-          <a:bodyPr wrap="square">
-            <a:spAutoFit/>
-          </a:bodyPr>
-          <a:lstStyle/>
-          <a:p>
-            <a:pPr>
-              <a:spcAft>
-                <a:spcPts val="800"/>
-              </a:spcAft>
-            </a:pPr>
-            <a:r>
-              <a:rPr sz="2600">
-                <a:solidFill>
-                  <a:srgbClr val="212121"/>
-                </a:solidFill>
-              </a:rPr>
-              <a:t>Session 2 — Hands-On</a:t>
-            </a:r>
-          </a:p>
-          <a:p>
-            <a:pPr>
-              <a:spcAft>
-                <a:spcPts val="800"/>
-              </a:spcAft>
-            </a:pPr>
-            <a:r>
-              <a:rPr sz="2600">
-                <a:solidFill>
-                  <a:srgbClr val="212121"/>
-                </a:solidFill>
-              </a:rPr>
-              <a:t>18:00 – 21:00</a:t>
-            </a:r>
-          </a:p>
-          <a:p>
-            <a:pPr>
-              <a:spcAft>
-                <a:spcPts val="800"/>
-              </a:spcAft>
-            </a:pPr>
-            <a:r>
-              <a:rPr sz="2600">
-                <a:solidFill>
-                  <a:srgbClr val="212121"/>
-                </a:solidFill>
-              </a:rPr>
-              <a:t>Tonight you drive.</a:t>
-            </a:r>
-          </a:p>
-        </p:txBody>
-      </p:sp>
-    </p:spTree>
-  </p:cSld>
-  <p:clrMapOvr>
-    <a:masterClrMapping/>
-  </p:clrMapOvr>
-</p:sld>
-</file>
-
-<file path=ppt/slides/slide14.xml><?xml version="1.0" encoding="utf-8"?>
-<p:sld xmlns:a="http://schemas.openxmlformats.org/drawingml/2006/main" xmlns:p="http://schemas.openxmlformats.org/presentationml/2006/main" xmlns:r="http://schemas.openxmlformats.org/officeDocument/2006/relationships">
-  <p:cSld>
-    <p:spTree>
-      <p:nvGrpSpPr>
-        <p:cNvPr id="1" name=""/>
-        <p:cNvGrpSpPr/>
-        <p:nvPr/>
-      </p:nvGrpSpPr>
-      <p:grpSpPr/>
-      <p:sp>
-        <p:nvSpPr>
-          <p:cNvPr id="2" name="TextBox 1"/>
-          <p:cNvSpPr txBox="1"/>
-          <p:nvPr/>
-        </p:nvSpPr>
-        <p:spPr>
-          <a:xfrm>
-            <a:off x="548640" y="365760"/>
-            <a:ext cx="11064240" cy="1005840"/>
-          </a:xfrm>
-          <a:prstGeom prst="rect">
-            <a:avLst/>
-          </a:prstGeom>
-          <a:noFill/>
-        </p:spPr>
-        <p:txBody>
-          <a:bodyPr wrap="square">
-            <a:spAutoFit/>
-          </a:bodyPr>
-          <a:lstStyle/>
-          <a:p>
-            <a:r>
-              <a:rPr sz="3600" b="1">
-                <a:solidFill>
-                  <a:srgbClr val="5A0A7A"/>
-                </a:solidFill>
-              </a:rPr>
-              <a:t>Recap quiz (while machines boot)</a:t>
-            </a:r>
-          </a:p>
-        </p:txBody>
-      </p:sp>
-      <p:sp>
-        <p:nvSpPr>
-          <p:cNvPr id="3" name="TextBox 2"/>
-          <p:cNvSpPr txBox="1"/>
-          <p:nvPr/>
-        </p:nvSpPr>
-        <p:spPr>
-          <a:xfrm>
-            <a:off x="731520" y="1463040"/>
-            <a:ext cx="10789920" cy="5120640"/>
-          </a:xfrm>
-          <a:prstGeom prst="rect">
-            <a:avLst/>
-          </a:prstGeom>
-          <a:noFill/>
-        </p:spPr>
-        <p:txBody>
-          <a:bodyPr wrap="square">
-            <a:spAutoFit/>
-          </a:bodyPr>
-          <a:lstStyle/>
-          <a:p>
-            <a:pPr>
-              <a:spcAft>
-                <a:spcPts val="800"/>
-              </a:spcAft>
-            </a:pPr>
-            <a:r>
-              <a:rPr sz="2400">
-                <a:solidFill>
-                  <a:srgbClr val="212121"/>
-                </a:solidFill>
-              </a:rPr>
-              <a:t>1. To prove property P with a solver, you ask whether … is satisfiable?</a:t>
-            </a:r>
-          </a:p>
-          <a:p>
-            <a:pPr>
-              <a:spcAft>
-                <a:spcPts val="800"/>
-              </a:spcAft>
-            </a:pPr>
-            <a:r>
-              <a:rPr sz="2400">
-                <a:solidFill>
-                  <a:srgbClr val="212121"/>
-                </a:solidFill>
-              </a:rPr>
-              <a:t>2. sat + a model in that setup means …?</a:t>
-            </a:r>
-          </a:p>
-          <a:p>
-            <a:pPr>
-              <a:spcAft>
-                <a:spcPts val="800"/>
-              </a:spcAft>
-            </a:pPr>
-            <a:r>
-              <a:rPr sz="2400">
-                <a:solidFill>
-                  <a:srgbClr val="212121"/>
-                </a:solidFill>
-              </a:rPr>
-              <a:t>3. --unwind 5 reports a violated unwinding assertion. Is the program buggy?</a:t>
-            </a:r>
-          </a:p>
-          <a:p>
-            <a:pPr>
-              <a:spcAft>
-                <a:spcPts val="800"/>
-              </a:spcAft>
-            </a:pPr>
-            <a:r>
-              <a:rPr sz="2400">
-                <a:solidFill>
-                  <a:srgbClr val="212121"/>
-                </a:solidFill>
-              </a:rPr>
-              <a:t/>
-            </a:r>
-          </a:p>
-          <a:p>
-            <a:pPr>
-              <a:spcAft>
-                <a:spcPts val="800"/>
-              </a:spcAft>
-            </a:pPr>
-            <a:r>
-              <a:rPr sz="2400">
-                <a:solidFill>
-                  <a:srgbClr val="212121"/>
-                </a:solidFill>
-              </a:rPr>
-              <a:t>Smoke test, everyone:</a:t>
-            </a:r>
-          </a:p>
-          <a:p>
-            <a:pPr>
-              <a:spcAft>
-                <a:spcPts val="0"/>
-              </a:spcAft>
-            </a:pPr>
-            <a:r>
-              <a:rPr sz="2000">
-                <a:solidFill>
-                  <a:srgbClr val="212121"/>
-                </a:solidFill>
-                <a:latin typeface="Courier New"/>
-              </a:rPr>
-              <a:t>esbmc lab4/float.c   →  VERIFICATION FAILED</a:t>
-            </a:r>
-          </a:p>
-        </p:txBody>
-      </p:sp>
-    </p:spTree>
-  </p:cSld>
-  <p:clrMapOvr>
-    <a:masterClrMapping/>
-  </p:clrMapOvr>
-</p:sld>
-</file>
-
-<file path=ppt/slides/slide15.xml><?xml version="1.0" encoding="utf-8"?>
-<p:sld xmlns:a="http://schemas.openxmlformats.org/drawingml/2006/main" xmlns:p="http://schemas.openxmlformats.org/presentationml/2006/main" xmlns:r="http://schemas.openxmlformats.org/officeDocument/2006/relationships">
-  <p:cSld>
-    <p:spTree>
-      <p:nvGrpSpPr>
-        <p:cNvPr id="1" name=""/>
-        <p:cNvGrpSpPr/>
-        <p:nvPr/>
-      </p:nvGrpSpPr>
-      <p:grpSpPr/>
-      <p:sp>
-        <p:nvSpPr>
-          <p:cNvPr id="2" name="TextBox 1"/>
-          <p:cNvSpPr txBox="1"/>
-          <p:nvPr/>
-        </p:nvSpPr>
-        <p:spPr>
-          <a:xfrm>
-            <a:off x="548640" y="365760"/>
-            <a:ext cx="11064240" cy="1005840"/>
-          </a:xfrm>
-          <a:prstGeom prst="rect">
-            <a:avLst/>
-          </a:prstGeom>
-          <a:noFill/>
-        </p:spPr>
-        <p:txBody>
-          <a:bodyPr wrap="square">
-            <a:spAutoFit/>
-          </a:bodyPr>
-          <a:lstStyle/>
-          <a:p>
-            <a:r>
-              <a:rPr sz="3600" b="1">
-                <a:solidFill>
-                  <a:srgbClr val="5A0A7A"/>
-                </a:solidFill>
-              </a:rPr>
-              <a:t>Tonight</a:t>
-            </a:r>
-          </a:p>
-        </p:txBody>
-      </p:sp>
-      <p:graphicFrame>
-        <p:nvGraphicFramePr>
-          <p:cNvPr id="3" name="Table 2"/>
-          <p:cNvGraphicFramePr>
-            <a:graphicFrameLocks noGrp="1"/>
-          </p:cNvGraphicFramePr>
-          <p:nvPr/>
-        </p:nvGraphicFramePr>
-        <p:xfrm>
-          <a:off x="731520" y="1463040"/>
-          <a:ext cx="10698480" cy="2194560"/>
-        </p:xfrm>
-        <a:graphic>
-          <a:graphicData uri="http://schemas.openxmlformats.org/drawingml/2006/table">
-            <a:tbl>
-              <a:tblPr firstRow="1" bandRow="1">
-                <a:tableStyleId>{5C22544A-7EE6-4342-B048-85BDC9FD1C3A}</a:tableStyleId>
-              </a:tblPr>
-              <a:tblGrid>
-                <a:gridCol w="1463040"/>
-                <a:gridCol w="1645920"/>
-                <a:gridCol w="7589520"/>
-              </a:tblGrid>
-              <a:tr h="365760">
-                <a:tc>
-                  <a:txBody>
-                    <a:bodyPr/>
-                    <a:lstStyle/>
-                    <a:p>
-                      <a:r>
-                        <a:rPr sz="2000" b="1"/>
-                        <a:t>18:15</a:t>
-                      </a:r>
-                    </a:p>
-                  </a:txBody>
-                  <a:tcPr/>
-                </a:tc>
-                <a:tc>
-                  <a:txBody>
-                    <a:bodyPr/>
-                    <a:lstStyle/>
-                    <a:p>
-                      <a:r>
-                        <a:rPr sz="2000" b="1"/>
-                        <a:t>Lab 1</a:t>
-                      </a:r>
-                    </a:p>
-                  </a:txBody>
-                  <a:tcPr/>
-                </a:tc>
-                <a:tc>
-                  <a:txBody>
-                    <a:bodyPr/>
-                    <a:lstStyle/>
-                    <a:p>
-                      <a:r>
-                        <a:rPr sz="2000" b="1"/>
-                        <a:t>Constraint solving with Z3</a:t>
-                      </a:r>
-                    </a:p>
-                  </a:txBody>
-                  <a:tcPr/>
-                </a:tc>
-              </a:tr>
-              <a:tr h="365760">
-                <a:tc>
-                  <a:txBody>
-                    <a:bodyPr/>
-                    <a:lstStyle/>
-                    <a:p>
-                      <a:r>
-                        <a:rPr sz="2000"/>
-                        <a:t>18:50</a:t>
-                      </a:r>
-                    </a:p>
-                  </a:txBody>
-                  <a:tcPr/>
-                </a:tc>
-                <a:tc>
-                  <a:txBody>
-                    <a:bodyPr/>
-                    <a:lstStyle/>
-                    <a:p>
-                      <a:r>
-                        <a:rPr sz="2000"/>
-                        <a:t>Lab 2</a:t>
-                      </a:r>
-                    </a:p>
-                  </a:txBody>
-                  <a:tcPr/>
-                </a:tc>
-                <a:tc>
-                  <a:txBody>
-                    <a:bodyPr/>
-                    <a:lstStyle/>
-                    <a:p>
-                      <a:r>
-                        <a:rPr sz="2000"/>
-                        <a:t>Bug hunting with ESBMC</a:t>
-                      </a:r>
-                    </a:p>
-                  </a:txBody>
-                  <a:tcPr/>
-                </a:tc>
-              </a:tr>
-              <a:tr h="365760">
-                <a:tc>
-                  <a:txBody>
-                    <a:bodyPr/>
-                    <a:lstStyle/>
-                    <a:p>
-                      <a:r>
-                        <a:rPr sz="2000"/>
-                        <a:t>19:30</a:t>
-                      </a:r>
-                    </a:p>
-                  </a:txBody>
-                  <a:tcPr/>
-                </a:tc>
-                <a:tc>
-                  <a:txBody>
-                    <a:bodyPr/>
-                    <a:lstStyle/>
-                    <a:p>
-                      <a:r>
-                        <a:rPr sz="2000"/>
-                        <a:t>Break</a:t>
-                      </a:r>
-                    </a:p>
-                  </a:txBody>
-                  <a:tcPr/>
-                </a:tc>
-                <a:tc>
-                  <a:txBody>
-                    <a:bodyPr/>
-                    <a:lstStyle/>
-                    <a:p/>
-                  </a:txBody>
-                  <a:tcPr/>
-                </a:tc>
-              </a:tr>
-              <a:tr h="365760">
-                <a:tc>
-                  <a:txBody>
-                    <a:bodyPr/>
-                    <a:lstStyle/>
-                    <a:p>
-                      <a:r>
-                        <a:rPr sz="2000"/>
-                        <a:t>19:40</a:t>
-                      </a:r>
-                    </a:p>
-                  </a:txBody>
-                  <a:tcPr/>
-                </a:tc>
-                <a:tc>
-                  <a:txBody>
-                    <a:bodyPr/>
-                    <a:lstStyle/>
-                    <a:p>
-                      <a:r>
-                        <a:rPr sz="2000"/>
-                        <a:t>Lab 3</a:t>
-                      </a:r>
-                    </a:p>
-                  </a:txBody>
-                  <a:tcPr/>
-                </a:tc>
-                <a:tc>
-                  <a:txBody>
-                    <a:bodyPr/>
-                    <a:lstStyle/>
-                    <a:p>
-                      <a:r>
-                        <a:rPr sz="2000"/>
-                        <a:t>Writing your own specifications</a:t>
-                      </a:r>
-                    </a:p>
-                  </a:txBody>
-                  <a:tcPr/>
-                </a:tc>
-              </a:tr>
-              <a:tr h="365760">
-                <a:tc>
-                  <a:txBody>
-                    <a:bodyPr/>
-                    <a:lstStyle/>
-                    <a:p>
-                      <a:r>
-                        <a:rPr sz="2000"/>
-                        <a:t>20:15</a:t>
-                      </a:r>
-                    </a:p>
-                  </a:txBody>
-                  <a:tcPr/>
-                </a:tc>
-                <a:tc>
-                  <a:txBody>
-                    <a:bodyPr/>
-                    <a:lstStyle/>
-                    <a:p>
-                      <a:r>
-                        <a:rPr sz="2000"/>
-                        <a:t>Lab 4</a:t>
-                      </a:r>
-                    </a:p>
-                  </a:txBody>
-                  <a:tcPr/>
-                </a:tc>
-                <a:tc>
-                  <a:txBody>
-                    <a:bodyPr/>
-                    <a:lstStyle/>
-                    <a:p>
-                      <a:r>
-                        <a:rPr sz="2000"/>
-                        <a:t>Team challenge</a:t>
-                      </a:r>
-                    </a:p>
-                  </a:txBody>
-                  <a:tcPr/>
-                </a:tc>
-              </a:tr>
-              <a:tr h="365760">
-                <a:tc>
-                  <a:txBody>
-                    <a:bodyPr/>
-                    <a:lstStyle/>
-                    <a:p>
-                      <a:r>
-                        <a:rPr sz="2000"/>
-                        <a:t>20:45</a:t>
-                      </a:r>
-                    </a:p>
-                  </a:txBody>
-                  <a:tcPr/>
-                </a:tc>
-                <a:tc>
-                  <a:txBody>
-                    <a:bodyPr/>
-                    <a:lstStyle/>
-                    <a:p/>
-                  </a:txBody>
-                  <a:tcPr/>
-                </a:tc>
-                <a:tc>
-                  <a:txBody>
-                    <a:bodyPr/>
-                    <a:lstStyle/>
-                    <a:p>
-                      <a:r>
-                        <a:rPr sz="2000"/>
-                        <a:t>Debrief + where next</a:t>
-                      </a:r>
-                    </a:p>
-                  </a:txBody>
-                  <a:tcPr/>
-                </a:tc>
-              </a:tr>
-            </a:tbl>
-          </a:graphicData>
-        </a:graphic>
-      </p:graphicFrame>
-      <p:sp>
-        <p:nvSpPr>
-          <p:cNvPr id="4" name="TextBox 3"/>
-          <p:cNvSpPr txBox="1"/>
-          <p:nvPr/>
-        </p:nvSpPr>
-        <p:spPr>
-          <a:xfrm>
-            <a:off x="731520" y="4206240"/>
-            <a:ext cx="10789920" cy="2377440"/>
-          </a:xfrm>
-          <a:prstGeom prst="rect">
-            <a:avLst/>
-          </a:prstGeom>
-          <a:noFill/>
-        </p:spPr>
-        <p:txBody>
-          <a:bodyPr wrap="square">
-            <a:spAutoFit/>
-          </a:bodyPr>
-          <a:lstStyle/>
-          <a:p>
-            <a:pPr>
-              <a:spcAft>
-                <a:spcPts val="800"/>
-              </a:spcAft>
-            </a:pPr>
-            <a:r>
-              <a:rPr sz="2200">
-                <a:solidFill>
-                  <a:srgbClr val="212121"/>
-                </a:solidFill>
-              </a:rPr>
-              <a:t>Work in pairs · keep labs/CHEATSHEET.md open · predict before you run</a:t>
-            </a:r>
-          </a:p>
-        </p:txBody>
-      </p:sp>
-    </p:spTree>
-  </p:cSld>
-  <p:clrMapOvr>
-    <a:masterClrMapping/>
-  </p:clrMapOvr>
-</p:sld>
-</file>
-
-<file path=ppt/slides/slide16.xml><?xml version="1.0" encoding="utf-8"?>
-<p:sld xmlns:a="http://schemas.openxmlformats.org/drawingml/2006/main" xmlns:p="http://schemas.openxmlformats.org/presentationml/2006/main" xmlns:r="http://schemas.openxmlformats.org/officeDocument/2006/relationships">
-  <p:cSld>
-    <p:spTree>
-      <p:nvGrpSpPr>
-        <p:cNvPr id="1" name=""/>
-        <p:cNvGrpSpPr/>
-        <p:nvPr/>
-      </p:nvGrpSpPr>
-      <p:grpSpPr/>
-      <p:sp>
-        <p:nvSpPr>
-          <p:cNvPr id="2" name="TextBox 1"/>
-          <p:cNvSpPr txBox="1"/>
-          <p:nvPr/>
-        </p:nvSpPr>
-        <p:spPr>
-          <a:xfrm>
-            <a:off x="548640" y="365760"/>
-            <a:ext cx="11064240" cy="1005840"/>
-          </a:xfrm>
-          <a:prstGeom prst="rect">
-            <a:avLst/>
-          </a:prstGeom>
-          <a:noFill/>
-        </p:spPr>
-        <p:txBody>
-          <a:bodyPr wrap="square">
-            <a:spAutoFit/>
-          </a:bodyPr>
-          <a:lstStyle/>
-          <a:p>
-            <a:r>
-              <a:rPr sz="3600" b="1">
-                <a:solidFill>
-                  <a:srgbClr val="5A0A7A"/>
-                </a:solidFill>
-              </a:rPr>
-              <a:t>Lab 1 — Constraint solving (35 min)</a:t>
-            </a:r>
-          </a:p>
-        </p:txBody>
-      </p:sp>
-      <p:sp>
-        <p:nvSpPr>
-          <p:cNvPr id="3" name="TextBox 2"/>
-          <p:cNvSpPr txBox="1"/>
-          <p:nvPr/>
-        </p:nvSpPr>
-        <p:spPr>
-          <a:xfrm>
-            <a:off x="731520" y="1463040"/>
-            <a:ext cx="10789920" cy="5120640"/>
-          </a:xfrm>
-          <a:prstGeom prst="rect">
-            <a:avLst/>
-          </a:prstGeom>
-          <a:noFill/>
-        </p:spPr>
-        <p:txBody>
-          <a:bodyPr wrap="square">
-            <a:spAutoFit/>
-          </a:bodyPr>
-          <a:lstStyle/>
-          <a:p>
-            <a:pPr>
-              <a:spcAft>
-                <a:spcPts val="800"/>
-              </a:spcAft>
-            </a:pPr>
-            <a:r>
-              <a:rPr sz="2200">
-                <a:solidFill>
-                  <a:srgbClr val="212121"/>
-                </a:solidFill>
-              </a:rPr>
-              <a:t>labs/lab1/lab1.py — three stages, instructions inside.</a:t>
-            </a:r>
-          </a:p>
-          <a:p>
-            <a:pPr>
-              <a:spcAft>
-                <a:spcPts val="800"/>
-              </a:spcAft>
-            </a:pPr>
-            <a:r>
-              <a:rPr sz="2200">
-                <a:solidFill>
-                  <a:srgbClr val="212121"/>
-                </a:solidFill>
-              </a:rPr>
-              <a:t>The one trick behind the whole evening:</a:t>
-            </a:r>
-          </a:p>
-          <a:p>
-            <a:pPr lvl="1">
-              <a:spcAft>
-                <a:spcPts val="800"/>
-              </a:spcAft>
-            </a:pPr>
-            <a:r>
-              <a:rPr sz="2000">
-                <a:solidFill>
-                  <a:srgbClr val="212121"/>
-                </a:solidFill>
-              </a:rPr>
-              <a:t>to prove P, ask the solver if ¬P is satisfiable.</a:t>
-            </a:r>
-          </a:p>
-          <a:p>
-            <a:pPr lvl="1">
-              <a:spcAft>
-                <a:spcPts val="800"/>
-              </a:spcAft>
-            </a:pPr>
-            <a:r>
-              <a:rPr sz="2000">
-                <a:solidFill>
-                  <a:srgbClr val="212121"/>
-                </a:solidFill>
-              </a:rPr>
-              <a:t>unsat ⇒ P holds.   A model ⇒ a counterexample.</a:t>
-            </a:r>
-          </a:p>
-          <a:p>
-            <a:pPr>
-              <a:spcAft>
-                <a:spcPts val="800"/>
-              </a:spcAft>
-            </a:pPr>
-            <a:r>
-              <a:rPr sz="2200">
-                <a:solidFill>
-                  <a:srgbClr val="212121"/>
-                </a:solidFill>
-              </a:rPr>
-              <a:t>Checkpoint before Lab 2: what does unsat mean in Stage 1 vs. Stage 3?</a:t>
-            </a:r>
-          </a:p>
-        </p:txBody>
-      </p:sp>
-    </p:spTree>
-  </p:cSld>
-  <p:clrMapOvr>
-    <a:masterClrMapping/>
-  </p:clrMapOvr>
-</p:sld>
-</file>
-
-<file path=ppt/slides/slide17.xml><?xml version="1.0" encoding="utf-8"?>
-<p:sld xmlns:a="http://schemas.openxmlformats.org/drawingml/2006/main" xmlns:p="http://schemas.openxmlformats.org/presentationml/2006/main" xmlns:r="http://schemas.openxmlformats.org/officeDocument/2006/relationships">
-  <p:cSld>
-    <p:spTree>
-      <p:nvGrpSpPr>
-        <p:cNvPr id="1" name=""/>
-        <p:cNvGrpSpPr/>
-        <p:nvPr/>
-      </p:nvGrpSpPr>
-      <p:grpSpPr/>
-      <p:sp>
-        <p:nvSpPr>
-          <p:cNvPr id="2" name="TextBox 1"/>
-          <p:cNvSpPr txBox="1"/>
-          <p:nvPr/>
-        </p:nvSpPr>
-        <p:spPr>
-          <a:xfrm>
-            <a:off x="548640" y="365760"/>
-            <a:ext cx="11064240" cy="1005840"/>
-          </a:xfrm>
-          <a:prstGeom prst="rect">
-            <a:avLst/>
-          </a:prstGeom>
-          <a:noFill/>
-        </p:spPr>
-        <p:txBody>
-          <a:bodyPr wrap="square">
-            <a:spAutoFit/>
-          </a:bodyPr>
-          <a:lstStyle/>
-          <a:p>
-            <a:r>
-              <a:rPr sz="3600" b="1">
-                <a:solidFill>
-                  <a:srgbClr val="5A0A7A"/>
-                </a:solidFill>
-              </a:rPr>
-              <a:t>Lab 2 — Bug hunting (40 min)</a:t>
-            </a:r>
-          </a:p>
-        </p:txBody>
-      </p:sp>
-      <p:sp>
-        <p:nvSpPr>
-          <p:cNvPr id="3" name="TextBox 2"/>
-          <p:cNvSpPr txBox="1"/>
-          <p:nvPr/>
-        </p:nvSpPr>
-        <p:spPr>
-          <a:xfrm>
-            <a:off x="731520" y="1371600"/>
-            <a:ext cx="10789920" cy="5212080"/>
-          </a:xfrm>
-          <a:prstGeom prst="rect">
-            <a:avLst/>
-          </a:prstGeom>
-          <a:noFill/>
-        </p:spPr>
-        <p:txBody>
-          <a:bodyPr wrap="square">
-            <a:spAutoFit/>
-          </a:bodyPr>
-          <a:lstStyle/>
-          <a:p>
-            <a:pPr>
-              <a:spcAft>
-                <a:spcPts val="800"/>
-              </a:spcAft>
-            </a:pPr>
-            <a:r>
-              <a:rPr sz="2200">
-                <a:solidFill>
-                  <a:srgbClr val="212121"/>
-                </a:solidFill>
-              </a:rPr>
-              <a:t>predict → verify → READ THE COUNTEREXAMPLE → fix → re-verify</a:t>
-            </a:r>
-          </a:p>
-        </p:txBody>
-      </p:sp>
-      <p:graphicFrame>
-        <p:nvGraphicFramePr>
-          <p:cNvPr id="4" name="Table 3"/>
-          <p:cNvGraphicFramePr>
-            <a:graphicFrameLocks noGrp="1"/>
-          </p:cNvGraphicFramePr>
-          <p:nvPr/>
-        </p:nvGraphicFramePr>
-        <p:xfrm>
-          <a:off x="731520" y="2103120"/>
-          <a:ext cx="7498080" cy="1828800"/>
-        </p:xfrm>
-        <a:graphic>
-          <a:graphicData uri="http://schemas.openxmlformats.org/drawingml/2006/table">
-            <a:tbl>
-              <a:tblPr firstRow="1" bandRow="1">
-                <a:tableStyleId>{5C22544A-7EE6-4342-B048-85BDC9FD1C3A}</a:tableStyleId>
-              </a:tblPr>
-              <a:tblGrid>
-                <a:gridCol w="731520"/>
-                <a:gridCol w="4754880"/>
-                <a:gridCol w="2011680"/>
-              </a:tblGrid>
-              <a:tr h="365760">
-                <a:tc>
-                  <a:txBody>
-                    <a:bodyPr/>
-                    <a:lstStyle/>
-                    <a:p>
-                      <a:r>
-                        <a:rPr sz="1800" b="1"/>
-                        <a:t>#</a:t>
-                      </a:r>
-                    </a:p>
-                  </a:txBody>
-                  <a:tcPr/>
-                </a:tc>
-                <a:tc>
-                  <a:txBody>
-                    <a:bodyPr/>
-                    <a:lstStyle/>
-                    <a:p>
-                      <a:r>
-                        <a:rPr sz="1800" b="1"/>
-                        <a:t>File</a:t>
-                      </a:r>
-                    </a:p>
-                  </a:txBody>
-                  <a:tcPr/>
-                </a:tc>
-                <a:tc>
-                  <a:txBody>
-                    <a:bodyPr/>
-                    <a:lstStyle/>
-                    <a:p>
-                      <a:r>
-                        <a:rPr sz="1800" b="1"/>
-                        <a:t>By</a:t>
-                      </a:r>
-                    </a:p>
-                  </a:txBody>
-                  <a:tcPr/>
-                </a:tc>
-              </a:tr>
-              <a:tr h="365760">
-                <a:tc>
-                  <a:txBody>
-                    <a:bodyPr/>
-                    <a:lstStyle/>
-                    <a:p>
-                      <a:r>
-                        <a:rPr sz="1800"/>
-                        <a:t>1</a:t>
-                      </a:r>
-                    </a:p>
-                  </a:txBody>
-                  <a:tcPr/>
-                </a:tc>
-                <a:tc>
-                  <a:txBody>
-                    <a:bodyPr/>
-                    <a:lstStyle/>
-                    <a:p>
-                      <a:r>
-                        <a:rPr sz="1800"/>
-                        <a:t>overflow.c</a:t>
-                      </a:r>
-                    </a:p>
-                  </a:txBody>
-                  <a:tcPr/>
-                </a:tc>
-                <a:tc>
-                  <a:txBody>
-                    <a:bodyPr/>
-                    <a:lstStyle/>
-                    <a:p>
-                      <a:r>
-                        <a:rPr sz="1800"/>
-                        <a:t>—</a:t>
-                      </a:r>
-                    </a:p>
-                  </a:txBody>
-                  <a:tcPr/>
-                </a:tc>
-              </a:tr>
-              <a:tr h="365760">
-                <a:tc>
-                  <a:txBody>
-                    <a:bodyPr/>
-                    <a:lstStyle/>
-                    <a:p>
-                      <a:r>
-                        <a:rPr sz="1800"/>
-                        <a:t>2</a:t>
-                      </a:r>
-                    </a:p>
-                  </a:txBody>
-                  <a:tcPr/>
-                </a:tc>
-                <a:tc>
-                  <a:txBody>
-                    <a:bodyPr/>
-                    <a:lstStyle/>
-                    <a:p>
-                      <a:r>
-                        <a:rPr sz="1800"/>
-                        <a:t>leak.c</a:t>
-                      </a:r>
-                    </a:p>
-                  </a:txBody>
-                  <a:tcPr/>
-                </a:tc>
-                <a:tc>
-                  <a:txBody>
-                    <a:bodyPr/>
-                    <a:lstStyle/>
-                    <a:p>
-                      <a:r>
-                        <a:rPr sz="1800"/>
-                        <a:t>19:05</a:t>
-                      </a:r>
-                    </a:p>
-                  </a:txBody>
-                  <a:tcPr/>
-                </a:tc>
-              </a:tr>
-              <a:tr h="365760">
-                <a:tc>
-                  <a:txBody>
-                    <a:bodyPr/>
-                    <a:lstStyle/>
-                    <a:p>
-                      <a:r>
-                        <a:rPr sz="1800"/>
-                        <a:t>3</a:t>
-                      </a:r>
-                    </a:p>
-                  </a:txBody>
-                  <a:tcPr/>
-                </a:tc>
-                <a:tc>
-                  <a:txBody>
-                    <a:bodyPr/>
-                    <a:lstStyle/>
-                    <a:p>
-                      <a:r>
-                        <a:rPr sz="1800"/>
-                        <a:t>vla.c  (two bugs!)</a:t>
-                      </a:r>
-                    </a:p>
-                  </a:txBody>
-                  <a:tcPr/>
-                </a:tc>
-                <a:tc>
-                  <a:txBody>
-                    <a:bodyPr/>
-                    <a:lstStyle/>
-                    <a:p>
-                      <a:r>
-                        <a:rPr sz="1800"/>
-                        <a:t>19:20</a:t>
-                      </a:r>
-                    </a:p>
-                  </a:txBody>
-                  <a:tcPr/>
-                </a:tc>
-              </a:tr>
-              <a:tr h="365760">
-                <a:tc>
-                  <a:txBody>
-                    <a:bodyPr/>
-                    <a:lstStyle/>
-                    <a:p>
-                      <a:r>
-                        <a:rPr sz="1800"/>
-                        <a:t>4</a:t>
-                      </a:r>
-                    </a:p>
-                  </a:txBody>
-                  <a:tcPr/>
-                </a:tc>
-                <a:tc>
-                  <a:txBody>
-                    <a:bodyPr/>
-                    <a:lstStyle/>
-                    <a:p>
-                      <a:r>
-                        <a:rPr sz="1800"/>
-                        <a:t>getpassword.c</a:t>
-                      </a:r>
-                    </a:p>
-                  </a:txBody>
-                  <a:tcPr/>
-                </a:tc>
-                <a:tc>
-                  <a:txBody>
-                    <a:bodyPr/>
-                    <a:lstStyle/>
-                    <a:p>
-                      <a:r>
-                        <a:rPr sz="1800"/>
-                        <a:t>stretch</a:t>
-                      </a:r>
-                    </a:p>
-                  </a:txBody>
-                  <a:tcPr/>
-                </a:tc>
-              </a:tr>
-            </a:tbl>
-          </a:graphicData>
-        </a:graphic>
-      </p:graphicFrame>
-      <p:sp>
-        <p:nvSpPr>
-          <p:cNvPr id="5" name="TextBox 4"/>
-          <p:cNvSpPr txBox="1"/>
-          <p:nvPr/>
-        </p:nvSpPr>
-        <p:spPr>
-          <a:xfrm>
-            <a:off x="731520" y="4754880"/>
-            <a:ext cx="10789920" cy="1828799"/>
-          </a:xfrm>
-          <a:prstGeom prst="rect">
-            <a:avLst/>
-          </a:prstGeom>
-          <a:noFill/>
-        </p:spPr>
-        <p:txBody>
-          <a:bodyPr wrap="square">
-            <a:spAutoFit/>
-          </a:bodyPr>
-          <a:lstStyle/>
-          <a:p>
-            <a:pPr>
-              <a:spcAft>
-                <a:spcPts val="800"/>
-              </a:spcAft>
-            </a:pPr>
-            <a:r>
-              <a:rPr sz="2000">
-                <a:solidFill>
-                  <a:srgbClr val="212121"/>
-                </a:solidFill>
-              </a:rPr>
-              <a:t>Done = VERIFICATION SUCCESSFUL on your fixed file, same flags.</a:t>
-            </a:r>
-          </a:p>
-          <a:p>
-            <a:pPr>
-              <a:spcAft>
-                <a:spcPts val="800"/>
-              </a:spcAft>
-            </a:pPr>
-            <a:r>
-              <a:rPr sz="2000">
-                <a:solidFill>
-                  <a:srgbClr val="212121"/>
-                </a:solidFill>
-              </a:rPr>
-              <a:t>Finished early? You are now a TA — help the pair next to you.</a:t>
-            </a:r>
-          </a:p>
-        </p:txBody>
-      </p:sp>
-    </p:spTree>
-  </p:cSld>
-  <p:clrMapOvr>
-    <a:masterClrMapping/>
-  </p:clrMapOvr>
-</p:sld>
-</file>
-
-<file path=ppt/slides/slide18.xml><?xml version="1.0" encoding="utf-8"?>
-<p:sld xmlns:a="http://schemas.openxmlformats.org/drawingml/2006/main" xmlns:p="http://schemas.openxmlformats.org/presentationml/2006/main" xmlns:r="http://schemas.openxmlformats.org/officeDocument/2006/relationships">
-  <p:cSld>
-    <p:spTree>
-      <p:nvGrpSpPr>
-        <p:cNvPr id="1" name=""/>
-        <p:cNvGrpSpPr/>
-        <p:nvPr/>
-      </p:nvGrpSpPr>
-      <p:grpSpPr/>
-      <p:sp>
-        <p:nvSpPr>
-          <p:cNvPr id="2" name="TextBox 1"/>
-          <p:cNvSpPr txBox="1"/>
-          <p:nvPr/>
-        </p:nvSpPr>
-        <p:spPr>
-          <a:xfrm>
-            <a:off x="548640" y="365760"/>
-            <a:ext cx="11064240" cy="1005840"/>
-          </a:xfrm>
-          <a:prstGeom prst="rect">
-            <a:avLst/>
-          </a:prstGeom>
-          <a:noFill/>
-        </p:spPr>
-        <p:txBody>
-          <a:bodyPr wrap="square">
-            <a:spAutoFit/>
-          </a:bodyPr>
-          <a:lstStyle/>
-          <a:p>
-            <a:r>
-              <a:rPr sz="3600" b="1">
-                <a:solidFill>
-                  <a:srgbClr val="5A0A7A"/>
-                </a:solidFill>
-              </a:rPr>
-              <a:t>Lab 3 — Specifications (35 min)</a:t>
-            </a:r>
-          </a:p>
-        </p:txBody>
-      </p:sp>
-      <p:sp>
-        <p:nvSpPr>
-          <p:cNvPr id="3" name="TextBox 2"/>
-          <p:cNvSpPr txBox="1"/>
-          <p:nvPr/>
-        </p:nvSpPr>
-        <p:spPr>
-          <a:xfrm>
-            <a:off x="731520" y="1828800"/>
-            <a:ext cx="10789920" cy="4754880"/>
-          </a:xfrm>
-          <a:prstGeom prst="rect">
-            <a:avLst/>
-          </a:prstGeom>
-          <a:noFill/>
-        </p:spPr>
-        <p:txBody>
-          <a:bodyPr wrap="square">
-            <a:spAutoFit/>
-          </a:bodyPr>
-          <a:lstStyle/>
-          <a:p>
-            <a:pPr>
-              <a:spcAft>
-                <a:spcPts val="800"/>
-              </a:spcAft>
-            </a:pPr>
-            <a:r>
-              <a:rPr sz="2800">
-                <a:solidFill>
-                  <a:srgbClr val="212121"/>
-                </a:solidFill>
-              </a:rPr>
-              <a:t>triangle.c verifies SUCCESSFUL as shipped.</a:t>
-            </a:r>
-          </a:p>
-          <a:p>
-            <a:pPr>
-              <a:spcAft>
-                <a:spcPts val="800"/>
-              </a:spcAft>
-            </a:pPr>
-            <a:r>
-              <a:rPr sz="2800">
-                <a:solidFill>
-                  <a:srgbClr val="212121"/>
-                </a:solidFill>
-              </a:rPr>
-              <a:t>Does that mean it's correct?</a:t>
-            </a:r>
-          </a:p>
-          <a:p>
-            <a:pPr>
-              <a:spcAft>
-                <a:spcPts val="800"/>
-              </a:spcAft>
-            </a:pPr>
-            <a:r>
-              <a:rPr sz="2800">
-                <a:solidFill>
-                  <a:srgbClr val="212121"/>
-                </a:solidFill>
-              </a:rPr>
-              <a:t>Write the two TODO properties and find out.</a:t>
-            </a:r>
-          </a:p>
-          <a:p>
-            <a:pPr>
-              <a:spcAft>
-                <a:spcPts val="800"/>
-              </a:spcAft>
-            </a:pPr>
-            <a:r>
-              <a:rPr sz="2800">
-                <a:solidFill>
-                  <a:srgbClr val="212121"/>
-                </a:solidFill>
-              </a:rPr>
-              <a:t/>
-            </a:r>
-          </a:p>
-          <a:p>
-            <a:pPr>
-              <a:spcAft>
-                <a:spcPts val="800"/>
-              </a:spcAft>
-            </a:pPr>
-            <a:r>
-              <a:rPr sz="2800">
-                <a:solidFill>
-                  <a:srgbClr val="212121"/>
-                </a:solidFill>
-              </a:rPr>
-              <a:t>The tool checks what you specify — with a weak spec, green is cheap.</a:t>
-            </a:r>
-          </a:p>
-        </p:txBody>
-      </p:sp>
-    </p:spTree>
-  </p:cSld>
-  <p:clrMapOvr>
-    <a:masterClrMapping/>
-  </p:clrMapOvr>
-</p:sld>
-</file>
-
-<file path=ppt/slides/slide19.xml><?xml version="1.0" encoding="utf-8"?>
-<p:sld xmlns:a="http://schemas.openxmlformats.org/drawingml/2006/main" xmlns:p="http://schemas.openxmlformats.org/presentationml/2006/main" xmlns:r="http://schemas.openxmlformats.org/officeDocument/2006/relationships">
-  <p:cSld>
-    <p:spTree>
-      <p:nvGrpSpPr>
-        <p:cNvPr id="1" name=""/>
-        <p:cNvGrpSpPr/>
-        <p:nvPr/>
-      </p:nvGrpSpPr>
-      <p:grpSpPr/>
-      <p:sp>
-        <p:nvSpPr>
-          <p:cNvPr id="2" name="TextBox 1"/>
-          <p:cNvSpPr txBox="1"/>
-          <p:nvPr/>
-        </p:nvSpPr>
-        <p:spPr>
-          <a:xfrm>
-            <a:off x="548640" y="365760"/>
-            <a:ext cx="11064240" cy="1005840"/>
-          </a:xfrm>
-          <a:prstGeom prst="rect">
-            <a:avLst/>
-          </a:prstGeom>
-          <a:noFill/>
-        </p:spPr>
-        <p:txBody>
-          <a:bodyPr wrap="square">
-            <a:spAutoFit/>
-          </a:bodyPr>
-          <a:lstStyle/>
-          <a:p>
-            <a:r>
-              <a:rPr sz="3600" b="1">
-                <a:solidFill>
-                  <a:srgbClr val="5A0A7A"/>
-                </a:solidFill>
-              </a:rPr>
-              <a:t>Lab 3, Part 2 — what did we prove?</a:t>
-            </a:r>
-          </a:p>
-        </p:txBody>
-      </p:sp>
-      <p:sp>
-        <p:nvSpPr>
-          <p:cNvPr id="3" name="TextBox 2"/>
-          <p:cNvSpPr txBox="1"/>
-          <p:nvPr/>
-        </p:nvSpPr>
-        <p:spPr>
-          <a:xfrm>
-            <a:off x="731520" y="1463040"/>
-            <a:ext cx="10789920" cy="5120640"/>
-          </a:xfrm>
-          <a:prstGeom prst="rect">
-            <a:avLst/>
-          </a:prstGeom>
-          <a:noFill/>
-        </p:spPr>
-        <p:txBody>
-          <a:bodyPr wrap="square">
-            <a:spAutoFit/>
-          </a:bodyPr>
-          <a:lstStyle/>
-          <a:p>
-            <a:pPr>
-              <a:spcAft>
-                <a:spcPts val="0"/>
-              </a:spcAft>
-            </a:pPr>
-            <a:r>
-              <a:rPr sz="1800">
-                <a:solidFill>
-                  <a:srgbClr val="212121"/>
-                </a:solidFill>
-                <a:latin typeface="Courier New"/>
-              </a:rPr>
-              <a:t>esbmc unwind.c --unwind 5      →  ?</a:t>
-            </a:r>
-          </a:p>
-          <a:p>
-            <a:pPr>
-              <a:spcAft>
-                <a:spcPts val="0"/>
-              </a:spcAft>
-            </a:pPr>
-            <a:r>
-              <a:rPr sz="1800">
-                <a:solidFill>
-                  <a:srgbClr val="212121"/>
-                </a:solidFill>
-                <a:latin typeface="Courier New"/>
-              </a:rPr>
-              <a:t>esbmc unwind.c --unwind 20     →  ?</a:t>
-            </a:r>
-          </a:p>
-          <a:p>
-            <a:pPr>
-              <a:spcAft>
-                <a:spcPts val="0"/>
-              </a:spcAft>
-            </a:pPr>
-            <a:r>
-              <a:rPr sz="1800">
-                <a:solidFill>
-                  <a:srgbClr val="212121"/>
-                </a:solidFill>
-                <a:latin typeface="Courier New"/>
-              </a:rPr>
-              <a:t>esbmc unwind.c --unwind 60     →  ?</a:t>
-            </a:r>
-          </a:p>
-          <a:p>
-            <a:pPr>
-              <a:spcAft>
-                <a:spcPts val="800"/>
-              </a:spcAft>
-            </a:pPr>
-            <a:r>
-              <a:rPr sz="2200">
-                <a:solidFill>
-                  <a:srgbClr val="212121"/>
-                </a:solidFill>
-              </a:rPr>
-              <a:t/>
-            </a:r>
-          </a:p>
-          <a:p>
-            <a:pPr>
-              <a:spcAft>
-                <a:spcPts val="800"/>
-              </a:spcAft>
-            </a:pPr>
-            <a:r>
-              <a:rPr sz="2200">
-                <a:solidFill>
-                  <a:srgbClr val="212121"/>
-                </a:solidFill>
-              </a:rPr>
-              <a:t>What is the unwinding assertion telling you at 5 and 20?</a:t>
-            </a:r>
-          </a:p>
-          <a:p>
-            <a:pPr>
-              <a:spcAft>
-                <a:spcPts val="800"/>
-              </a:spcAft>
-            </a:pPr>
-            <a:r>
-              <a:rPr sz="2200">
-                <a:solidFill>
-                  <a:srgbClr val="212121"/>
-                </a:solidFill>
-              </a:rPr>
-              <a:t>At 60 — what exactly is proven, and for which n?</a:t>
-            </a:r>
-          </a:p>
-          <a:p>
-            <a:pPr>
-              <a:spcAft>
-                <a:spcPts val="800"/>
-              </a:spcAft>
-            </a:pPr>
-            <a:r>
-              <a:rPr sz="2200">
-                <a:solidFill>
-                  <a:srgbClr val="212121"/>
-                </a:solidFill>
-              </a:rPr>
-              <a:t>Stretch: --k-induction answers VERIFICATION UNKNOWN. Why is the unbounded question fundamentally harder?</a:t>
             </a:r>
           </a:p>
         </p:txBody>
@@ -5492,410 +3993,6 @@
           </a:graphicData>
         </a:graphic>
       </p:graphicFrame>
-    </p:spTree>
-  </p:cSld>
-  <p:clrMapOvr>
-    <a:masterClrMapping/>
-  </p:clrMapOvr>
-</p:sld>
-</file>
-
-<file path=ppt/slides/slide20.xml><?xml version="1.0" encoding="utf-8"?>
-<p:sld xmlns:a="http://schemas.openxmlformats.org/drawingml/2006/main" xmlns:p="http://schemas.openxmlformats.org/presentationml/2006/main" xmlns:r="http://schemas.openxmlformats.org/officeDocument/2006/relationships">
-  <p:cSld>
-    <p:spTree>
-      <p:nvGrpSpPr>
-        <p:cNvPr id="1" name=""/>
-        <p:cNvGrpSpPr/>
-        <p:nvPr/>
-      </p:nvGrpSpPr>
-      <p:grpSpPr/>
-      <p:sp>
-        <p:nvSpPr>
-          <p:cNvPr id="2" name="TextBox 1"/>
-          <p:cNvSpPr txBox="1"/>
-          <p:nvPr/>
-        </p:nvSpPr>
-        <p:spPr>
-          <a:xfrm>
-            <a:off x="548640" y="365760"/>
-            <a:ext cx="11064240" cy="1005840"/>
-          </a:xfrm>
-          <a:prstGeom prst="rect">
-            <a:avLst/>
-          </a:prstGeom>
-          <a:noFill/>
-        </p:spPr>
-        <p:txBody>
-          <a:bodyPr wrap="square">
-            <a:spAutoFit/>
-          </a:bodyPr>
-          <a:lstStyle/>
-          <a:p>
-            <a:r>
-              <a:rPr sz="3600" b="1">
-                <a:solidFill>
-                  <a:srgbClr val="5A0A7A"/>
-                </a:solidFill>
-              </a:rPr>
-              <a:t>Lab 4 — Team challenge (30 min)</a:t>
-            </a:r>
-          </a:p>
-        </p:txBody>
-      </p:sp>
-      <p:sp>
-        <p:nvSpPr>
-          <p:cNvPr id="3" name="TextBox 2"/>
-          <p:cNvSpPr txBox="1"/>
-          <p:nvPr/>
-        </p:nvSpPr>
-        <p:spPr>
-          <a:xfrm>
-            <a:off x="731520" y="1463040"/>
-            <a:ext cx="10789920" cy="5120640"/>
-          </a:xfrm>
-          <a:prstGeom prst="rect">
-            <a:avLst/>
-          </a:prstGeom>
-          <a:noFill/>
-        </p:spPr>
-        <p:txBody>
-          <a:bodyPr wrap="square">
-            <a:spAutoFit/>
-          </a:bodyPr>
-          <a:lstStyle/>
-          <a:p>
-            <a:pPr>
-              <a:spcAft>
-                <a:spcPts val="800"/>
-              </a:spcAft>
-            </a:pPr>
-            <a:r>
-              <a:rPr sz="2200">
-                <a:solidFill>
-                  <a:srgbClr val="212121"/>
-                </a:solidFill>
-              </a:rPr>
-              <a:t>Teams of 3–4. Points on the whiteboard:</a:t>
-            </a:r>
-          </a:p>
-          <a:p>
-            <a:pPr lvl="1">
-              <a:spcAft>
-                <a:spcPts val="800"/>
-              </a:spcAft>
-            </a:pPr>
-            <a:r>
-              <a:rPr sz="2000">
-                <a:solidFill>
-                  <a:srgbClr val="212121"/>
-                </a:solidFill>
-              </a:rPr>
-              <a:t>1 pt — verdict predicted correctly in writing, before running</a:t>
-            </a:r>
-          </a:p>
-          <a:p>
-            <a:pPr lvl="1">
-              <a:spcAft>
-                <a:spcPts val="800"/>
-              </a:spcAft>
-            </a:pPr>
-            <a:r>
-              <a:rPr sz="2000">
-                <a:solidFill>
-                  <a:srgbClr val="212121"/>
-                </a:solidFill>
-              </a:rPr>
-              <a:t>2 pts — file fixed and re-verified</a:t>
-            </a:r>
-          </a:p>
-          <a:p>
-            <a:pPr>
-              <a:spcAft>
-                <a:spcPts val="800"/>
-              </a:spcAft>
-            </a:pPr>
-            <a:r>
-              <a:rPr sz="2200">
-                <a:solidFill>
-                  <a:srgbClr val="212121"/>
-                </a:solidFill>
-              </a:rPr>
-              <a:t/>
-            </a:r>
-          </a:p>
-          <a:p>
-            <a:pPr>
-              <a:spcAft>
-                <a:spcPts val="800"/>
-              </a:spcAft>
-            </a:pPr>
-            <a:r>
-              <a:rPr sz="2200">
-                <a:solidFill>
-                  <a:srgbClr val="212121"/>
-                </a:solidFill>
-              </a:rPr>
-              <a:t>Track A:  race.c — write down the failing interleaving first, then</a:t>
-            </a:r>
-          </a:p>
-          <a:p>
-            <a:pPr>
-              <a:spcAft>
-                <a:spcPts val="0"/>
-              </a:spcAft>
-            </a:pPr>
-            <a:r>
-              <a:rPr sz="1800">
-                <a:solidFill>
-                  <a:srgbClr val="212121"/>
-                </a:solidFill>
-                <a:latin typeface="Courier New"/>
-              </a:rPr>
-              <a:t>esbmc race.c --context-bound 2</a:t>
-            </a:r>
-          </a:p>
-          <a:p>
-            <a:pPr>
-              <a:spcAft>
-                <a:spcPts val="800"/>
-              </a:spcAft>
-            </a:pPr>
-            <a:r>
-              <a:rPr sz="2200">
-                <a:solidFill>
-                  <a:srgbClr val="212121"/>
-                </a:solidFill>
-              </a:rPr>
-              <a:t>Track B:  float.c — primary-school arithmetic. Or is it?</a:t>
-            </a:r>
-          </a:p>
-        </p:txBody>
-      </p:sp>
-    </p:spTree>
-  </p:cSld>
-  <p:clrMapOvr>
-    <a:masterClrMapping/>
-  </p:clrMapOvr>
-</p:sld>
-</file>
-
-<file path=ppt/slides/slide21.xml><?xml version="1.0" encoding="utf-8"?>
-<p:sld xmlns:a="http://schemas.openxmlformats.org/drawingml/2006/main" xmlns:p="http://schemas.openxmlformats.org/presentationml/2006/main" xmlns:r="http://schemas.openxmlformats.org/officeDocument/2006/relationships">
-  <p:cSld>
-    <p:spTree>
-      <p:nvGrpSpPr>
-        <p:cNvPr id="1" name=""/>
-        <p:cNvGrpSpPr/>
-        <p:nvPr/>
-      </p:nvGrpSpPr>
-      <p:grpSpPr/>
-      <p:sp>
-        <p:nvSpPr>
-          <p:cNvPr id="2" name="TextBox 1"/>
-          <p:cNvSpPr txBox="1"/>
-          <p:nvPr/>
-        </p:nvSpPr>
-        <p:spPr>
-          <a:xfrm>
-            <a:off x="548640" y="365760"/>
-            <a:ext cx="11064240" cy="1005840"/>
-          </a:xfrm>
-          <a:prstGeom prst="rect">
-            <a:avLst/>
-          </a:prstGeom>
-          <a:noFill/>
-        </p:spPr>
-        <p:txBody>
-          <a:bodyPr wrap="square">
-            <a:spAutoFit/>
-          </a:bodyPr>
-          <a:lstStyle/>
-          <a:p>
-            <a:r>
-              <a:rPr sz="3600" b="1">
-                <a:solidFill>
-                  <a:srgbClr val="5A0A7A"/>
-                </a:solidFill>
-              </a:rPr>
-              <a:t>Debrief</a:t>
-            </a:r>
-          </a:p>
-        </p:txBody>
-      </p:sp>
-      <p:sp>
-        <p:nvSpPr>
-          <p:cNvPr id="3" name="TextBox 2"/>
-          <p:cNvSpPr txBox="1"/>
-          <p:nvPr/>
-        </p:nvSpPr>
-        <p:spPr>
-          <a:xfrm>
-            <a:off x="731520" y="1463040"/>
-            <a:ext cx="10789920" cy="5120640"/>
-          </a:xfrm>
-          <a:prstGeom prst="rect">
-            <a:avLst/>
-          </a:prstGeom>
-          <a:noFill/>
-        </p:spPr>
-        <p:txBody>
-          <a:bodyPr wrap="square">
-            <a:spAutoFit/>
-          </a:bodyPr>
-          <a:lstStyle/>
-          <a:p>
-            <a:pPr>
-              <a:spcAft>
-                <a:spcPts val="800"/>
-              </a:spcAft>
-            </a:pPr>
-            <a:r>
-              <a:rPr sz="2200">
-                <a:solidFill>
-                  <a:srgbClr val="212121"/>
-                </a:solidFill>
-              </a:rPr>
-              <a:t>One thing the tool caught that YOU wouldn't have?</a:t>
-            </a:r>
-          </a:p>
-          <a:p>
-            <a:pPr>
-              <a:spcAft>
-                <a:spcPts val="800"/>
-              </a:spcAft>
-            </a:pPr>
-            <a:r>
-              <a:rPr sz="2200">
-                <a:solidFill>
-                  <a:srgbClr val="212121"/>
-                </a:solidFill>
-              </a:rPr>
-              <a:t>The arc you just walked: intuition → concepts → tools → application</a:t>
-            </a:r>
-          </a:p>
-          <a:p>
-            <a:pPr>
-              <a:spcAft>
-                <a:spcPts val="800"/>
-              </a:spcAft>
-            </a:pPr>
-            <a:r>
-              <a:rPr sz="2200">
-                <a:solidFill>
-                  <a:srgbClr val="212121"/>
-                </a:solidFill>
-              </a:rPr>
-              <a:t/>
-            </a:r>
-          </a:p>
-          <a:p>
-            <a:pPr>
-              <a:spcAft>
-                <a:spcPts val="800"/>
-              </a:spcAft>
-            </a:pPr>
-            <a:r>
-              <a:rPr sz="2200">
-                <a:solidFill>
-                  <a:srgbClr val="212121"/>
-                </a:solidFill>
-              </a:rPr>
-              <a:t>Where next:</a:t>
-            </a:r>
-          </a:p>
-          <a:p>
-            <a:pPr lvl="1">
-              <a:spcAft>
-                <a:spcPts val="800"/>
-              </a:spcAft>
-            </a:pPr>
-            <a:r>
-              <a:rPr sz="2000">
-                <a:solidFill>
-                  <a:srgbClr val="212121"/>
-                </a:solidFill>
-              </a:rPr>
-              <a:t>SV-COMP benchmarks: sv-comp.sosy-lab.org</a:t>
-            </a:r>
-          </a:p>
-          <a:p>
-            <a:pPr lvl="1">
-              <a:spcAft>
-                <a:spcPts val="800"/>
-              </a:spcAft>
-            </a:pPr>
-            <a:r>
-              <a:rPr sz="2000">
-                <a:solidFill>
-                  <a:srgbClr val="212121"/>
-                </a:solidFill>
-              </a:rPr>
-              <a:t>Full course: COMP63342 Software Security (slides online)</a:t>
-            </a:r>
-          </a:p>
-          <a:p>
-            <a:pPr lvl="1">
-              <a:spcAft>
-                <a:spcPts val="800"/>
-              </a:spcAft>
-            </a:pPr>
-            <a:r>
-              <a:rPr sz="2000">
-                <a:solidFill>
-                  <a:srgbClr val="212121"/>
-                </a:solidFill>
-              </a:rPr>
-              <a:t>ESBMC: esbmc.org · Z3: github.com/Z3Prover/z3</a:t>
-            </a:r>
-          </a:p>
-          <a:p>
-            <a:pPr lvl="1">
-              <a:spcAft>
-                <a:spcPts val="800"/>
-              </a:spcAft>
-            </a:pPr>
-            <a:r>
-              <a:rPr sz="2000">
-                <a:solidFill>
-                  <a:srgbClr val="212121"/>
-                </a:solidFill>
-              </a:rPr>
-              <a:t>The complementary technique: fuzzing (AFL, OSS-Fuzz)</a:t>
-            </a:r>
-          </a:p>
-          <a:p>
-            <a:pPr>
-              <a:spcAft>
-                <a:spcPts val="800"/>
-              </a:spcAft>
-            </a:pPr>
-            <a:r>
-              <a:rPr sz="2200">
-                <a:solidFill>
-                  <a:srgbClr val="212121"/>
-                </a:solidFill>
-              </a:rPr>
-              <a:t/>
-            </a:r>
-          </a:p>
-          <a:p>
-            <a:pPr>
-              <a:spcAft>
-                <a:spcPts val="800"/>
-              </a:spcAft>
-            </a:pPr>
-            <a:r>
-              <a:rPr sz="2200">
-                <a:solidFill>
-                  <a:srgbClr val="212121"/>
-                </a:solidFill>
-              </a:rPr>
-              <a:t>Feedback poll: pace / best lab / one improvement. Thank you!</a:t>
-            </a:r>
-          </a:p>
-        </p:txBody>
-      </p:sp>
     </p:spTree>
   </p:cSld>
   <p:clrMapOvr>

</xml_diff>